<commit_message>
Add presentation and final README
</commit_message>
<xml_diff>
--- a/presentation/road_accidents_presentation.pptx
+++ b/presentation/road_accidents_presentation.pptx
@@ -6413,139 +6413,6 @@
                 <a:latin typeface="Calibri"/>
               </a:rPr>
               <a:t>Speed control on extra-urban roads</a:t>
-            </a:r>
-          </a:p>
-        </p:txBody>
-      </p:sp>
-      <p:sp>
-        <p:nvSpPr>
-          <p:cNvPr id="15" name="TextBox 14"/>
-          <p:cNvSpPr txBox="1"/>
-          <p:nvPr/>
-        </p:nvSpPr>
-        <p:spPr>
-          <a:xfrm>
-            <a:off x="731520" y="4389120"/>
-            <a:ext cx="10698480" cy="457200"/>
-          </a:xfrm>
-          <a:prstGeom prst="rect">
-            <a:avLst/>
-          </a:prstGeom>
-          <a:noFill/>
-        </p:spPr>
-        <p:txBody>
-          <a:bodyPr wrap="square">
-            <a:spAutoFit/>
-          </a:bodyPr>
-          <a:lstStyle/>
-          <a:p>
-            <a:pPr algn="l">
-              <a:spcAft>
-                <a:spcPts val="1000"/>
-              </a:spcAft>
-            </a:pPr>
-            <a:r>
-              <a:rPr sz="1800" b="1">
-                <a:solidFill>
-                  <a:srgbClr val="1F4E79"/>
-                </a:solidFill>
-                <a:latin typeface="Calibri"/>
-              </a:rPr>
-              <a:t>Limits</a:t>
-            </a:r>
-          </a:p>
-        </p:txBody>
-      </p:sp>
-      <p:sp>
-        <p:nvSpPr>
-          <p:cNvPr id="16" name="TextBox 15"/>
-          <p:cNvSpPr txBox="1"/>
-          <p:nvPr/>
-        </p:nvSpPr>
-        <p:spPr>
-          <a:xfrm>
-            <a:off x="731520" y="4846320"/>
-            <a:ext cx="10698480" cy="914400"/>
-          </a:xfrm>
-          <a:prstGeom prst="rect">
-            <a:avLst/>
-          </a:prstGeom>
-          <a:noFill/>
-        </p:spPr>
-        <p:txBody>
-          <a:bodyPr wrap="square">
-            <a:spAutoFit/>
-          </a:bodyPr>
-          <a:lstStyle/>
-          <a:p>
-            <a:pPr algn="l">
-              <a:spcAft>
-                <a:spcPts val="600"/>
-              </a:spcAft>
-            </a:pPr>
-            <a:r>
-              <a:rPr sz="1600" b="0">
-                <a:solidFill>
-                  <a:srgbClr val="222222"/>
-                </a:solidFill>
-                <a:latin typeface="Calibri"/>
-              </a:rPr>
-              <a:t>- Only accidents with injured people or deaths</a:t>
-            </a:r>
-          </a:p>
-          <a:p>
-            <a:pPr algn="l">
-              <a:spcAft>
-                <a:spcPts val="600"/>
-              </a:spcAft>
-            </a:pPr>
-            <a:r>
-              <a:rPr sz="1600" b="0">
-                <a:solidFill>
-                  <a:srgbClr val="222222"/>
-                </a:solidFill>
-                <a:latin typeface="Calibri"/>
-              </a:rPr>
-              <a:t>- Rates use residents only, so tourist towns look more dangerous</a:t>
-            </a:r>
-          </a:p>
-        </p:txBody>
-      </p:sp>
-      <p:sp>
-        <p:nvSpPr>
-          <p:cNvPr id="17" name="TextBox 16"/>
-          <p:cNvSpPr txBox="1"/>
-          <p:nvPr/>
-        </p:nvSpPr>
-        <p:spPr>
-          <a:xfrm>
-            <a:off x="731520" y="6035040"/>
-            <a:ext cx="10698480" cy="457200"/>
-          </a:xfrm>
-          <a:prstGeom prst="rect">
-            <a:avLst/>
-          </a:prstGeom>
-          <a:noFill/>
-        </p:spPr>
-        <p:txBody>
-          <a:bodyPr wrap="square">
-            <a:spAutoFit/>
-          </a:bodyPr>
-          <a:lstStyle/>
-          <a:p>
-            <a:pPr algn="l">
-              <a:spcAft>
-                <a:spcPts val="1000"/>
-              </a:spcAft>
-            </a:pPr>
-            <a:r>
-              <a:rPr sz="1400" b="0">
-                <a:solidFill>
-                  <a:srgbClr val="666666"/>
-                </a:solidFill>
-                <a:latin typeface="Calibri"/>
-              </a:rPr>
-              <a:t>Project: github.com/aledoll01-sys/progetto_finale</a:t>
             </a:r>
           </a:p>
         </p:txBody>

</xml_diff>